<commit_message>
Finalize submission wording and regenerate reviewed deliverables
</commit_message>
<xml_diff>
--- a/presentation.pptx
+++ b/presentation.pptx
@@ -500,7 +500,7 @@
             <a:spLocks noGrp="1"/>
           </p:cNvSpPr>
           <p:nvPr>
-            <p:ph type="body" idx="3" sz="quarter"/>
+            <p:ph type="body" sz="quarter" idx="3"/>
           </p:nvPr>
         </p:nvSpPr>
         <p:spPr/>
@@ -521,10 +521,30 @@
             <a:spLocks noGrp="1"/>
           </p:cNvSpPr>
           <p:nvPr>
-            <p:ph type="sldNum" idx="5" sz="quarter"/>
-          </p:nvPr>
-        </p:nvSpPr>
-        <p:spPr/>
+            <p:ph type="sldNum" sz="quarter" idx="5"/>
+          </p:nvPr>
+        </p:nvSpPr>
+        <p:spPr/>
+      </p:sp>
+      <p:sp>
+        <p:nvSpPr>
+          <p:cNvPr id="3" name="Notes Placeholder 2"/>
+          <p:cNvSpPr/>
+          <p:nvPr>
+            <p:ph type="body" idx="1"/>
+          </p:nvPr>
+        </p:nvSpPr>
+        <p:spPr/>
+        <p:txBody>
+          <a:bodyPr/>
+          <a:lstStyle/>
+          <a:p>
+            <a:r>
+              <a:rPr lang="en-US"/>
+              <a:t>We study how quantum state preparation and noise affect reconstruction of the ANNNI phase diagram. The central result is a tradeoff: fewer entangling gates improve noisy correlations, and mitigation helps under a genuinely matched gate-weighted measurement budget. But neither improvement alone certifies a phase boundary. We keep the failed preparations, detector rejections and floating-scan results in the submission. The notebook contains the full numerical evidence and a lightweight circuit check.</a:t>
+            </a:r>
+          </a:p>
+        </p:txBody>
       </p:sp>
     </p:spTree>
   </p:cSld>
@@ -570,7 +590,7 @@
             <a:spLocks noGrp="1"/>
           </p:cNvSpPr>
           <p:nvPr>
-            <p:ph type="body" idx="3" sz="quarter"/>
+            <p:ph type="body" sz="quarter" idx="3"/>
           </p:nvPr>
         </p:nvSpPr>
         <p:spPr/>
@@ -591,10 +611,30 @@
             <a:spLocks noGrp="1"/>
           </p:cNvSpPr>
           <p:nvPr>
-            <p:ph type="sldNum" idx="5" sz="quarter"/>
-          </p:nvPr>
-        </p:nvSpPr>
-        <p:spPr/>
+            <p:ph type="sldNum" sz="quarter" idx="5"/>
+          </p:nvPr>
+        </p:nvSpPr>
+        <p:spPr/>
+      </p:sp>
+      <p:sp>
+        <p:nvSpPr>
+          <p:cNvPr id="3" name="Notes Placeholder 2"/>
+          <p:cNvSpPr/>
+          <p:nvPr>
+            <p:ph type="body" idx="1"/>
+          </p:nvPr>
+        </p:nvSpPr>
+        <p:spPr/>
+        <p:txBody>
+          <a:bodyPr/>
+          <a:lstStyle/>
+          <a:p>
+            <a:r>
+              <a:rPr lang="en-US"/>
+              <a:t>The Hamiltonian has ferromagnetic nearest-neighbor coupling, competing next-nearest-neighbor coupling and a transverse field. We use periodic boundaries for the small circuits. Noise follows every literal CNOT, on its target only, with the same specified channel at all three noise strengths. Reference preparation and folding count as gates. Three evidence layers prevent a detector from grading itself: supported interiors, same-size exact-diagonalization features, and larger-system evidence. Our observables retain every distance and momentum, including the self-correlation background.</a:t>
+            </a:r>
+          </a:p>
+        </p:txBody>
       </p:sp>
     </p:spTree>
   </p:cSld>
@@ -640,7 +680,7 @@
             <a:spLocks noGrp="1"/>
           </p:cNvSpPr>
           <p:nvPr>
-            <p:ph type="body" idx="3" sz="quarter"/>
+            <p:ph type="body" sz="quarter" idx="3"/>
           </p:nvPr>
         </p:nvSpPr>
         <p:spPr/>
@@ -661,10 +701,30 @@
             <a:spLocks noGrp="1"/>
           </p:cNvSpPr>
           <p:nvPr>
-            <p:ph type="sldNum" idx="5" sz="quarter"/>
-          </p:nvPr>
-        </p:nvSpPr>
-        <p:spPr/>
+            <p:ph type="sldNum" sz="quarter" idx="5"/>
+          </p:nvPr>
+        </p:nvSpPr>
+        <p:spPr/>
+      </p:sp>
+      <p:sp>
+        <p:nvSpPr>
+          <p:cNvPr id="3" name="Notes Placeholder 2"/>
+          <p:cNvSpPr/>
+          <p:nvPr>
+            <p:ph type="body" idx="1"/>
+          </p:nvPr>
+        </p:nvSpPr>
+        <p:spPr/>
+        <p:txBody>
+          <a:bodyPr/>
+          <a:lstStyle/>
+          <a:p>
+            <a:r>
+              <a:rPr lang="en-US"/>
+              <a:t>B0 is the original fixed six-layer Hamiltonian variational ansatz. B3 starts from several physical references and grows energy-optimized Pauli rotations, then uses a frozen energy and resource rule. The median CNOT count is halved, from 192 to 96. Ideal joint preparation coverage drops from 407 to 385 out of 420, so the method does not win on every metric. At noise probability one percent, mean maximum correlation error falls from 0.2638 to 0.1432, with improvement at 402 coordinates. This is an observable result, not phase-label accuracy.</a:t>
+            </a:r>
+          </a:p>
+        </p:txBody>
       </p:sp>
     </p:spTree>
   </p:cSld>
@@ -710,7 +770,7 @@
             <a:spLocks noGrp="1"/>
           </p:cNvSpPr>
           <p:nvPr>
-            <p:ph type="body" idx="3" sz="quarter"/>
+            <p:ph type="body" sz="quarter" idx="3"/>
           </p:nvPr>
         </p:nvSpPr>
         <p:spPr/>
@@ -731,10 +791,30 @@
             <a:spLocks noGrp="1"/>
           </p:cNvSpPr>
           <p:nvPr>
-            <p:ph type="sldNum" idx="5" sz="quarter"/>
-          </p:nvPr>
-        </p:nvSpPr>
-        <p:spPr/>
+            <p:ph type="sldNum" sz="quarter" idx="5"/>
+          </p:nvPr>
+        </p:nvSpPr>
+        <p:spPr/>
+      </p:sp>
+      <p:sp>
+        <p:nvSpPr>
+          <p:cNvPr id="3" name="Notes Placeholder 2"/>
+          <p:cNvSpPr/>
+          <p:nvPr>
+            <p:ph type="body" idx="1"/>
+          </p:nvPr>
+        </p:nvSpPr>
+        <p:spPr/>
+        <p:txBody>
+          <a:bodyPr/>
+          <a:lstStyle/>
+          <a:p>
+            <a:r>
+              <a:rPr lang="en-US"/>
+              <a:t>These are the required three noise maps, alongside the same detector applied to ED data. The method, grid and legend remain fixed across noise levels. The colors show resemblance to physical patterns, not independently validated truth at every coordinate. Crosses indicate failed ideal preparation without hiding the label. Our notebook separately displays single-repeat finite-shot maps and equal-shots mitigation maps. It also shows where independent region labels exist. We never extend the smaller equal-resource cohort into a full equal-resource map.</a:t>
+            </a:r>
+          </a:p>
+        </p:txBody>
       </p:sp>
     </p:spTree>
   </p:cSld>
@@ -780,7 +860,7 @@
             <a:spLocks noGrp="1"/>
           </p:cNvSpPr>
           <p:nvPr>
-            <p:ph type="body" idx="3" sz="quarter"/>
+            <p:ph type="body" sz="quarter" idx="3"/>
           </p:nvPr>
         </p:nvSpPr>
         <p:spPr/>
@@ -801,10 +881,30 @@
             <a:spLocks noGrp="1"/>
           </p:cNvSpPr>
           <p:nvPr>
-            <p:ph type="sldNum" idx="5" sz="quarter"/>
-          </p:nvPr>
-        </p:nvSpPr>
-        <p:spPr/>
+            <p:ph type="sldNum" sz="quarter" idx="5"/>
+          </p:nvPr>
+        </p:nvSpPr>
+        <p:spPr/>
+      </p:sp>
+      <p:sp>
+        <p:nvSpPr>
+          <p:cNvPr id="3" name="Notes Placeholder 2"/>
+          <p:cNvSpPr/>
+          <p:nvPr>
+            <p:ph type="body" idx="1"/>
+          </p:nvPr>
+        </p:nvSpPr>
+        <p:spPr/>
+        <p:txBody>
+          <a:bodyPr/>
+          <a:lstStyle/>
+          <a:p>
+            <a:r>
+              <a:rPr lang="en-US"/>
+              <a:t>Equal shot counts alone favor extrapolation with more noisy gates. We therefore match the sum of shots times literal CNOTs at each coordinate. Raw and symmetry verification use one hundred thousand shots, whereas quadratic ZNE uses thirty-three thousand three hundred and thirty-four shots shared across the three folds. The integer gate-weighted costs match exactly. At p=.01 and .05 the mean ED-target MSE falls by 90.75 and 25.19 percent. Each of the 45 coordinate means improves. ZNE worsens all 45 at zero noise. It reduces bias while increasing sampling error, and only six coordinates have independent phase-interior labels.</a:t>
+            </a:r>
+          </a:p>
+        </p:txBody>
       </p:sp>
     </p:spTree>
   </p:cSld>
@@ -850,7 +950,7 @@
             <a:spLocks noGrp="1"/>
           </p:cNvSpPr>
           <p:nvPr>
-            <p:ph type="body" idx="3" sz="quarter"/>
+            <p:ph type="body" sz="quarter" idx="3"/>
           </p:nvPr>
         </p:nvSpPr>
         <p:spPr/>
@@ -871,10 +971,30 @@
             <a:spLocks noGrp="1"/>
           </p:cNvSpPr>
           <p:nvPr>
-            <p:ph type="sldNum" idx="5" sz="quarter"/>
-          </p:nvPr>
-        </p:nvSpPr>
-        <p:spPr/>
+            <p:ph type="sldNum" sz="quarter" idx="5"/>
+          </p:nvPr>
+        </p:nvSpPr>
+        <p:spPr/>
+      </p:sp>
+      <p:sp>
+        <p:nvSpPr>
+          <p:cNvPr id="3" name="Notes Placeholder 2"/>
+          <p:cNvSpPr/>
+          <p:nvPr>
+            <p:ph type="body" idx="1"/>
+          </p:nvPr>
+        </p:nvSpPr>
+        <p:spPr/>
+        <p:txBody>
+          <a:bodyPr/>
+          <a:lstStyle/>
+          <a:p>
+            <a:r>
+              <a:rPr lang="en-US"/>
+              <a:t>The prespecified kappa point eight window illustrates the distinct outcomes of observable reconstruction and response-feature matching. These curves use exact expectations so shot fluctuations cannot explain every failure. All six windows were actually executed. Five reference features are resolvable; the kappa point five reference fails the frozen peak-selection criterion. At strong noise, the equal-shots raw result matches roughly three of those five windows when averaged over measurement repeats, and extrapolation does not improve that aggregate. We retain endpoint and multiple-peak warnings, preparation failures and real same-coordinate branch comparisons. A match with no listed warning is still not proof of a thermodynamic transition.</a:t>
+            </a:r>
+          </a:p>
+        </p:txBody>
       </p:sp>
     </p:spTree>
   </p:cSld>
@@ -920,7 +1040,7 @@
             <a:spLocks noGrp="1"/>
           </p:cNvSpPr>
           <p:nvPr>
-            <p:ph type="body" idx="3" sz="quarter"/>
+            <p:ph type="body" sz="quarter" idx="3"/>
           </p:nvPr>
         </p:nvSpPr>
         <p:spPr/>
@@ -941,10 +1061,30 @@
             <a:spLocks noGrp="1"/>
           </p:cNvSpPr>
           <p:nvPr>
-            <p:ph type="sldNum" idx="5" sz="quarter"/>
-          </p:nvPr>
-        </p:nvSpPr>
-        <p:spPr/>
+            <p:ph type="sldNum" sz="quarter" idx="5"/>
+          </p:nvPr>
+        </p:nvSpPr>
+        <p:spPr/>
+      </p:sp>
+      <p:sp>
+        <p:nvSpPr>
+          <p:cNvPr id="3" name="Notes Placeholder 2"/>
+          <p:cNvSpPr/>
+          <p:nvPr>
+            <p:ph type="body" idx="1"/>
+          </p:nvPr>
+        </p:nvSpPr>
+        <p:spPr/>
+        <p:txBody>
+          <a:bodyPr/>
+          <a:lstStyle/>
+          <a:p>
+            <a:r>
+              <a:rPr lang="en-US"/>
+              <a:t>The newer physical and domain-wall construction improves selected joint passes in the independent low-field confirmation subset, from 27 to 37 out of 48. However, median CNOTs increase from 32 to 127 and objective calls increase by about seven and a half times. H6 therefore is not an equal-cost universal winner. Its transfer to the N12 difficult/control set is weaker than B3. The five extension topics remain in the package: larger circuits, multiple detectors, mitigation, dynamics, and the floating-phase search. The negative transfer result is preserved rather than removed from the final story.</a:t>
+            </a:r>
+          </a:p>
+        </p:txBody>
       </p:sp>
     </p:spTree>
   </p:cSld>
@@ -990,7 +1130,7 @@
             <a:spLocks noGrp="1"/>
           </p:cNvSpPr>
           <p:nvPr>
-            <p:ph type="body" idx="3" sz="quarter"/>
+            <p:ph type="body" sz="quarter" idx="3"/>
           </p:nvPr>
         </p:nvSpPr>
         <p:spPr/>
@@ -1011,10 +1151,30 @@
             <a:spLocks noGrp="1"/>
           </p:cNvSpPr>
           <p:nvPr>
-            <p:ph type="sldNum" idx="5" sz="quarter"/>
-          </p:nvPr>
-        </p:nvSpPr>
-        <p:spPr/>
+            <p:ph type="sldNum" sz="quarter" idx="5"/>
+          </p:nvPr>
+        </p:nvSpPr>
+        <p:spPr/>
+      </p:sp>
+      <p:sp>
+        <p:nvSpPr>
+          <p:cNvPr id="3" name="Notes Placeholder 2"/>
+          <p:cNvSpPr/>
+          <p:nvPr>
+            <p:ph type="body" idx="1"/>
+          </p:nvPr>
+        </p:nvSpPr>
+        <p:spPr/>
+        <p:txBody>
+          <a:bodyPr/>
+          <a:lstStyle/>
+          <a:p>
+            <a:r>
+              <a:rPr lang="en-US"/>
+              <a:t>The controlled large-system slice supports an antiphase control at field point three and a paramagnetic-side control at point seven. Fields point four and point four two five have conflicting size, entropy and Friedel results. The final evidence contains zero supported floating samples and zero established transition brackets. A timed-out high-bond-dimension continuation is not evidence against a phase. Our conclusion is therefore specific: lower-gate preparation and resource-controlled mitigation improve observable reconstruction, while reliable boundary inference needs stronger evidence. The submission ships saved joint counts, gate tables, reproducible figures, and separate deterministic, physical and random-replay checks.</a:t>
+            </a:r>
+          </a:p>
+        </p:txBody>
       </p:sp>
     </p:spTree>
   </p:cSld>
@@ -3486,7 +3646,7 @@
 </file>
 
 <file path=ppt/slideMasters/slideMaster1.xml><?xml version="1.0" encoding="utf-8"?>
-<p:sldMaster xmlns:a="http://schemas.openxmlformats.org/drawingml/2006/main" xmlns:r="http://schemas.openxmlformats.org/officeDocument/2006/relationships" xmlns:p="http://schemas.openxmlformats.org/presentationml/2006/main">
+<p:sldMaster xmlns:p14="http://schemas.microsoft.com/office/powerpoint/2010/main" xmlns:a="http://schemas.openxmlformats.org/drawingml/2006/main" xmlns:r="http://schemas.openxmlformats.org/officeDocument/2006/relationships" xmlns:p="http://schemas.openxmlformats.org/presentationml/2006/main">
   <p:cSld>
     <p:bg>
       <p:bgRef idx="1001">
@@ -4022,7 +4182,7 @@
           <a:noFill/>
         </p:spPr>
         <p:txBody>
-          <a:bodyPr wrap="square" lIns="0" rIns="0" tIns="0">
+          <a:bodyPr wrap="square" lIns="0" tIns="0" rIns="0">
             <a:spAutoFit/>
           </a:bodyPr>
           <a:lstStyle/>
@@ -4039,6 +4199,10 @@
               </a:defRPr>
             </a:pPr>
             <a:r>
+              <a:rPr sz="3600" b="1">
+                <a:latin typeface="Arial"/>
+                <a:ea typeface="Arial"/>
+              </a:rPr>
               <a:t>Noise-Aware ANNNI</a:t>
             </a:r>
           </a:p>
@@ -4055,6 +4219,10 @@
               </a:defRPr>
             </a:pPr>
             <a:r>
+              <a:rPr sz="3600" b="1">
+                <a:latin typeface="Arial"/>
+                <a:ea typeface="Arial"/>
+              </a:rPr>
               <a:t>Phase Diagnostics</a:t>
             </a:r>
           </a:p>
@@ -4077,7 +4245,7 @@
           <a:noFill/>
         </p:spPr>
         <p:txBody>
-          <a:bodyPr wrap="square" lIns="0" rIns="0" tIns="0">
+          <a:bodyPr wrap="square" lIns="0" tIns="0" rIns="0">
             <a:spAutoFit/>
           </a:bodyPr>
           <a:lstStyle/>
@@ -4094,6 +4262,10 @@
               </a:defRPr>
             </a:pPr>
             <a:r>
+              <a:rPr sz="2000" b="0">
+                <a:latin typeface="Arial"/>
+                <a:ea typeface="Arial"/>
+              </a:rPr>
               <a:t>Low-CNOT preparation, error mitigation, and their limits</a:t>
             </a:r>
           </a:p>
@@ -4116,7 +4288,7 @@
           <a:noFill/>
         </p:spPr>
         <p:txBody>
-          <a:bodyPr wrap="square" lIns="0" rIns="0" tIns="0">
+          <a:bodyPr wrap="square" lIns="0" tIns="0" rIns="0">
             <a:spAutoFit/>
           </a:bodyPr>
           <a:lstStyle/>
@@ -4133,6 +4305,10 @@
               </a:defRPr>
             </a:pPr>
             <a:r>
+              <a:rPr sz="1800" b="0">
+                <a:latin typeface="Arial"/>
+                <a:ea typeface="Arial"/>
+              </a:rPr>
               <a:t>Q-SITE 2026 / Scientific Track</a:t>
             </a:r>
           </a:p>
@@ -4149,6 +4325,10 @@
               </a:defRPr>
             </a:pPr>
             <a:r>
+              <a:rPr sz="1800" b="0">
+                <a:latin typeface="Arial"/>
+                <a:ea typeface="Arial"/>
+              </a:rPr>
               <a:t>Team hamster</a:t>
             </a:r>
           </a:p>
@@ -4165,6 +4345,10 @@
               </a:defRPr>
             </a:pPr>
             <a:r>
+              <a:rPr sz="1800" b="0">
+                <a:latin typeface="Arial"/>
+                <a:ea typeface="Arial"/>
+              </a:rPr>
               <a:t>Shupei Zhang, Yangxin Zhou, Michael Li, Kathy Chen</a:t>
             </a:r>
           </a:p>
@@ -4179,7 +4363,7 @@
           <p:nvPr/>
         </p:nvPicPr>
         <p:blipFill>
-          <a:blip r:embed="rId2"/>
+          <a:blip r:embed="Rc2f4955a69534081"/>
           <a:stretch>
             <a:fillRect/>
           </a:stretch>
@@ -4187,7 +4371,7 @@
         <p:spPr>
           <a:xfrm>
             <a:off x="1723297" y="3429000"/>
-            <a:ext cx="8745100" cy="2606040"/>
+            <a:ext cx="8745101" cy="2606040"/>
           </a:xfrm>
           <a:prstGeom prst="rect">
             <a:avLst/>
@@ -4211,7 +4395,7 @@
           <a:noFill/>
         </p:spPr>
         <p:txBody>
-          <a:bodyPr wrap="square" lIns="0" rIns="0" tIns="0">
+          <a:bodyPr wrap="square" lIns="0" tIns="0" rIns="0">
             <a:spAutoFit/>
           </a:bodyPr>
           <a:lstStyle/>
@@ -4268,7 +4452,7 @@
           <a:noFill/>
         </p:spPr>
         <p:txBody>
-          <a:bodyPr wrap="square" lIns="0" rIns="0" tIns="0">
+          <a:bodyPr wrap="square" lIns="0" tIns="0" rIns="0">
             <a:spAutoFit/>
           </a:bodyPr>
           <a:lstStyle/>
@@ -4285,6 +4469,10 @@
               </a:defRPr>
             </a:pPr>
             <a:r>
+              <a:rPr sz="3600" b="1">
+                <a:latin typeface="Arial"/>
+                <a:ea typeface="Arial"/>
+              </a:rPr>
               <a:t>Model and evidence layers</a:t>
             </a:r>
           </a:p>
@@ -4307,7 +4495,7 @@
           <a:noFill/>
         </p:spPr>
         <p:txBody>
-          <a:bodyPr wrap="square" lIns="0" rIns="0" tIns="0">
+          <a:bodyPr wrap="square" lIns="0" tIns="0" rIns="0">
             <a:spAutoFit/>
           </a:bodyPr>
           <a:lstStyle/>
@@ -4324,6 +4512,10 @@
               </a:defRPr>
             </a:pPr>
             <a:r>
+              <a:rPr sz="2000" b="0">
+                <a:latin typeface="Arial"/>
+                <a:ea typeface="Arial"/>
+              </a:rPr>
               <a:t>Periodic N8/N12 circuits; large-size OBC evidence kept separate</a:t>
             </a:r>
           </a:p>
@@ -4346,7 +4538,7 @@
           <a:noFill/>
         </p:spPr>
         <p:txBody>
-          <a:bodyPr wrap="square" lIns="0" rIns="0" tIns="0">
+          <a:bodyPr wrap="square" lIns="0" tIns="0" rIns="0">
             <a:spAutoFit/>
           </a:bodyPr>
           <a:lstStyle/>
@@ -4363,6 +4555,10 @@
               </a:defRPr>
             </a:pPr>
             <a:r>
+              <a:rPr sz="1800" b="0">
+                <a:latin typeface="Arial"/>
+                <a:ea typeface="Arial"/>
+              </a:rPr>
               <a:t>H = -sum ZZ(nn) + kappa sum ZZ(nnn) - h sum X</a:t>
             </a:r>
           </a:p>
@@ -4379,6 +4575,10 @@
               </a:defRPr>
             </a:pPr>
             <a:r>
+              <a:rPr sz="1800" b="0">
+                <a:latin typeface="Arial"/>
+                <a:ea typeface="Arial"/>
+              </a:rPr>
               <a:t>Every CNOT: target-only depolarizing channel</a:t>
             </a:r>
           </a:p>
@@ -4395,6 +4595,10 @@
               </a:defRPr>
             </a:pPr>
             <a:r>
+              <a:rPr sz="1800" b="0">
+                <a:latin typeface="Arial"/>
+                <a:ea typeface="Arial"/>
+              </a:rPr>
               <a:t>R0 interiors / RN finite-size features / Rlarge trends</a:t>
             </a:r>
           </a:p>
@@ -4409,7 +4613,7 @@
           <p:nvPr/>
         </p:nvPicPr>
         <p:blipFill>
-          <a:blip r:embed="rId2"/>
+          <a:blip r:embed="Rf43ba9d0239848d1"/>
           <a:stretch>
             <a:fillRect/>
           </a:stretch>
@@ -4441,7 +4645,7 @@
           <a:noFill/>
         </p:spPr>
         <p:txBody>
-          <a:bodyPr wrap="square" lIns="0" rIns="0" tIns="0">
+          <a:bodyPr wrap="square" lIns="0" tIns="0" rIns="0">
             <a:spAutoFit/>
           </a:bodyPr>
           <a:lstStyle/>
@@ -4498,7 +4702,7 @@
           <a:noFill/>
         </p:spPr>
         <p:txBody>
-          <a:bodyPr wrap="square" lIns="0" rIns="0" tIns="0">
+          <a:bodyPr wrap="square" lIns="0" tIns="0" rIns="0">
             <a:spAutoFit/>
           </a:bodyPr>
           <a:lstStyle/>
@@ -4515,6 +4719,10 @@
               </a:defRPr>
             </a:pPr>
             <a:r>
+              <a:rPr sz="3600" b="1">
+                <a:latin typeface="Arial"/>
+                <a:ea typeface="Arial"/>
+              </a:rPr>
               <a:t>Fewer gates, different tradeoffs</a:t>
             </a:r>
           </a:p>
@@ -4537,7 +4745,7 @@
           <a:noFill/>
         </p:spPr>
         <p:txBody>
-          <a:bodyPr wrap="square" lIns="0" rIns="0" tIns="0">
+          <a:bodyPr wrap="square" lIns="0" tIns="0" rIns="0">
             <a:spAutoFit/>
           </a:bodyPr>
           <a:lstStyle/>
@@ -4554,6 +4762,10 @@
               </a:defRPr>
             </a:pPr>
             <a:r>
+              <a:rPr sz="2000" b="0">
+                <a:latin typeface="Arial"/>
+                <a:ea typeface="Arial"/>
+              </a:rPr>
               <a:t>B0 fixed six-layer HVA -&gt; B3 multi-reference adaptive preparation</a:t>
             </a:r>
           </a:p>
@@ -4576,7 +4788,7 @@
           <a:noFill/>
         </p:spPr>
         <p:txBody>
-          <a:bodyPr wrap="square" lIns="0" rIns="0" tIns="0">
+          <a:bodyPr wrap="square" lIns="0" tIns="0" rIns="0">
             <a:spAutoFit/>
           </a:bodyPr>
           <a:lstStyle/>
@@ -4593,6 +4805,10 @@
               </a:defRPr>
             </a:pPr>
             <a:r>
+              <a:rPr sz="1800" b="0">
+                <a:latin typeface="Arial"/>
+                <a:ea typeface="Arial"/>
+              </a:rPr>
               <a:t>Median CNOTs: 192 -&gt; 96</a:t>
             </a:r>
           </a:p>
@@ -4609,6 +4825,10 @@
               </a:defRPr>
             </a:pPr>
             <a:r>
+              <a:rPr sz="1800" b="0">
+                <a:latin typeface="Arial"/>
+                <a:ea typeface="Arial"/>
+              </a:rPr>
               <a:t>Ideal joint passes: 407/420 -&gt; 385/420</a:t>
             </a:r>
           </a:p>
@@ -4625,6 +4845,10 @@
               </a:defRPr>
             </a:pPr>
             <a:r>
+              <a:rPr sz="1800" b="0">
+                <a:latin typeface="Arial"/>
+                <a:ea typeface="Arial"/>
+              </a:rPr>
               <a:t>p=.01 correlation error improves at 402/420 points</a:t>
             </a:r>
           </a:p>
@@ -4639,14 +4863,14 @@
           <p:nvPr/>
         </p:nvPicPr>
         <p:blipFill>
-          <a:blip r:embed="rId2"/>
+          <a:blip r:embed="R58ecb7e12a6a400e"/>
           <a:stretch>
             <a:fillRect/>
           </a:stretch>
         </p:blipFill>
         <p:spPr>
           <a:xfrm>
-            <a:off x="1032894" y="2971800"/>
+            <a:off x="1032895" y="2971800"/>
             <a:ext cx="10125906" cy="3017520"/>
           </a:xfrm>
           <a:prstGeom prst="rect">
@@ -4671,7 +4895,7 @@
           <a:noFill/>
         </p:spPr>
         <p:txBody>
-          <a:bodyPr wrap="square" lIns="0" rIns="0" tIns="0">
+          <a:bodyPr wrap="square" lIns="0" tIns="0" rIns="0">
             <a:spAutoFit/>
           </a:bodyPr>
           <a:lstStyle/>
@@ -4728,7 +4952,7 @@
           <a:noFill/>
         </p:spPr>
         <p:txBody>
-          <a:bodyPr wrap="square" lIns="0" rIns="0" tIns="0">
+          <a:bodyPr wrap="square" lIns="0" tIns="0" rIns="0">
             <a:spAutoFit/>
           </a:bodyPr>
           <a:lstStyle/>
@@ -4745,6 +4969,10 @@
               </a:defRPr>
             </a:pPr>
             <a:r>
+              <a:rPr sz="3600" b="1">
+                <a:latin typeface="Arial"/>
+                <a:ea typeface="Arial"/>
+              </a:rPr>
               <a:t>Three noise levels, one diagnostic</a:t>
             </a:r>
           </a:p>
@@ -4767,7 +4995,7 @@
           <a:noFill/>
         </p:spPr>
         <p:txBody>
-          <a:bodyPr wrap="square" lIns="0" rIns="0" tIns="0">
+          <a:bodyPr wrap="square" lIns="0" tIns="0" rIns="0">
             <a:spAutoFit/>
           </a:bodyPr>
           <a:lstStyle/>
@@ -4784,6 +5012,10 @@
               </a:defRPr>
             </a:pPr>
             <a:r>
+              <a:rPr sz="2000" b="0">
+                <a:latin typeface="Arial"/>
+                <a:ea typeface="Arial"/>
+              </a:rPr>
               <a:t>Frozen D3; exact expectations; identical 420-point grid</a:t>
             </a:r>
           </a:p>
@@ -4806,7 +5038,7 @@
           <a:noFill/>
         </p:spPr>
         <p:txBody>
-          <a:bodyPr wrap="square" lIns="0" rIns="0" tIns="0">
+          <a:bodyPr wrap="square" lIns="0" tIns="0" rIns="0">
             <a:spAutoFit/>
           </a:bodyPr>
           <a:lstStyle/>
@@ -4823,6 +5055,10 @@
               </a:defRPr>
             </a:pPr>
             <a:r>
+              <a:rPr sz="1800" b="0">
+                <a:latin typeface="Arial"/>
+                <a:ea typeface="Arial"/>
+              </a:rPr>
               <a:t>Colors: estimated phase-like regions</a:t>
             </a:r>
           </a:p>
@@ -4839,6 +5075,10 @@
               </a:defRPr>
             </a:pPr>
             <a:r>
+              <a:rPr sz="1800" b="0">
+                <a:latin typeface="Arial"/>
+                <a:ea typeface="Arial"/>
+              </a:rPr>
               <a:t>Crosses: ideal preparation failed</a:t>
             </a:r>
           </a:p>
@@ -4855,7 +5095,11 @@
               </a:defRPr>
             </a:pPr>
             <a:r>
-              <a:t>Uncertain and degraded remain distinct</a:t>
+              <a:rPr sz="1800" b="0">
+                <a:latin typeface="Arial"/>
+                <a:ea typeface="Arial"/>
+              </a:rPr>
+              <a:t>Unassigned and degraded are separate classes</a:t>
             </a:r>
           </a:p>
         </p:txBody>
@@ -4869,14 +5113,14 @@
           <p:nvPr/>
         </p:nvPicPr>
         <p:blipFill>
-          <a:blip r:embed="rId2"/>
+          <a:blip r:embed="R3bc8ece5b5344ffa"/>
           <a:stretch>
             <a:fillRect/>
           </a:stretch>
         </p:blipFill>
         <p:spPr>
           <a:xfrm>
-            <a:off x="2362067" y="2971800"/>
+            <a:off x="2362068" y="2971800"/>
             <a:ext cx="7467559" cy="3017520"/>
           </a:xfrm>
           <a:prstGeom prst="rect">
@@ -4901,7 +5145,7 @@
           <a:noFill/>
         </p:spPr>
         <p:txBody>
-          <a:bodyPr wrap="square" lIns="0" rIns="0" tIns="0">
+          <a:bodyPr wrap="square" lIns="0" tIns="0" rIns="0">
             <a:spAutoFit/>
           </a:bodyPr>
           <a:lstStyle/>
@@ -4958,7 +5202,7 @@
           <a:noFill/>
         </p:spPr>
         <p:txBody>
-          <a:bodyPr wrap="square" lIns="0" rIns="0" tIns="0">
+          <a:bodyPr wrap="square" lIns="0" tIns="0" rIns="0">
             <a:spAutoFit/>
           </a:bodyPr>
           <a:lstStyle/>
@@ -4975,6 +5219,10 @@
               </a:defRPr>
             </a:pPr>
             <a:r>
+              <a:rPr sz="3600" b="1">
+                <a:latin typeface="Arial"/>
+                <a:ea typeface="Arial"/>
+              </a:rPr>
               <a:t>Mitigation at equal CNOT-shots</a:t>
             </a:r>
           </a:p>
@@ -4997,7 +5245,7 @@
           <a:noFill/>
         </p:spPr>
         <p:txBody>
-          <a:bodyPr wrap="square" lIns="0" rIns="0" tIns="0">
+          <a:bodyPr wrap="square" lIns="0" tIns="0" rIns="0">
             <a:spAutoFit/>
           </a:bodyPr>
           <a:lstStyle/>
@@ -5014,6 +5262,10 @@
               </a:defRPr>
             </a:pPr>
             <a:r>
+              <a:rPr sz="2000" b="0">
+                <a:latin typeface="Arial"/>
+                <a:ea typeface="Arial"/>
+              </a:rPr>
               <a:t>45 fixed coordinates / 32 repeats / unchanged 17-component MSE</a:t>
             </a:r>
           </a:p>
@@ -5036,7 +5288,7 @@
           <a:noFill/>
         </p:spPr>
         <p:txBody>
-          <a:bodyPr wrap="square" lIns="0" rIns="0" tIns="0">
+          <a:bodyPr wrap="square" lIns="0" tIns="0" rIns="0">
             <a:spAutoFit/>
           </a:bodyPr>
           <a:lstStyle/>
@@ -5053,6 +5305,10 @@
               </a:defRPr>
             </a:pPr>
             <a:r>
+              <a:rPr sz="1800" b="0">
+                <a:latin typeface="Arial"/>
+                <a:ea typeface="Arial"/>
+              </a:rPr>
               <a:t>G = 100,000 x original CNOT count</a:t>
             </a:r>
           </a:p>
@@ -5069,6 +5325,10 @@
               </a:defRPr>
             </a:pPr>
             <a:r>
+              <a:rPr sz="1800" b="0">
+                <a:latin typeface="Arial"/>
+                <a:ea typeface="Arial"/>
+              </a:rPr>
               <a:t>Raw / SV: 100k shots; ZNE: 33,334</a:t>
             </a:r>
           </a:p>
@@ -5085,6 +5345,10 @@
               </a:defRPr>
             </a:pPr>
             <a:r>
+              <a:rPr sz="1800" b="0">
+                <a:latin typeface="Arial"/>
+                <a:ea typeface="Arial"/>
+              </a:rPr>
               <a:t>ZNE MSE decrease: 90.75% / 25.19%</a:t>
             </a:r>
           </a:p>
@@ -5099,7 +5363,7 @@
           <p:nvPr/>
         </p:nvPicPr>
         <p:blipFill>
-          <a:blip r:embed="rId2"/>
+          <a:blip r:embed="Rc8a4a7e2a2fb4a5b"/>
           <a:stretch>
             <a:fillRect/>
           </a:stretch>
@@ -5131,7 +5395,7 @@
           <a:noFill/>
         </p:spPr>
         <p:txBody>
-          <a:bodyPr wrap="square" lIns="0" rIns="0" tIns="0">
+          <a:bodyPr wrap="square" lIns="0" tIns="0" rIns="0">
             <a:spAutoFit/>
           </a:bodyPr>
           <a:lstStyle/>
@@ -5188,7 +5452,7 @@
           <a:noFill/>
         </p:spPr>
         <p:txBody>
-          <a:bodyPr wrap="square" lIns="0" rIns="0" tIns="0">
+          <a:bodyPr wrap="square" lIns="0" tIns="0" rIns="0">
             <a:spAutoFit/>
           </a:bodyPr>
           <a:lstStyle/>
@@ -5205,6 +5469,10 @@
               </a:defRPr>
             </a:pPr>
             <a:r>
+              <a:rPr sz="3600" b="1">
+                <a:latin typeface="Arial"/>
+                <a:ea typeface="Arial"/>
+              </a:rPr>
               <a:t>Better observables, unstable features</a:t>
             </a:r>
           </a:p>
@@ -5227,7 +5495,7 @@
           <a:noFill/>
         </p:spPr>
         <p:txBody>
-          <a:bodyPr wrap="square" lIns="0" rIns="0" tIns="0">
+          <a:bodyPr wrap="square" lIns="0" tIns="0" rIns="0">
             <a:spAutoFit/>
           </a:bodyPr>
           <a:lstStyle/>
@@ -5244,7 +5512,11 @@
               </a:defRPr>
             </a:pPr>
             <a:r>
-              <a:t>Six complete 17-point windows; only five resolvable references</a:t>
+              <a:rPr sz="2000" b="0">
+                <a:latin typeface="Arial"/>
+                <a:ea typeface="Arial"/>
+              </a:rPr>
+              <a:t>Six complete 17-point windows; five references pass peak selection</a:t>
             </a:r>
           </a:p>
         </p:txBody>
@@ -5266,7 +5538,7 @@
           <a:noFill/>
         </p:spPr>
         <p:txBody>
-          <a:bodyPr wrap="square" lIns="0" rIns="0" tIns="0">
+          <a:bodyPr wrap="square" lIns="0" tIns="0" rIns="0">
             <a:spAutoFit/>
           </a:bodyPr>
           <a:lstStyle/>
@@ -5283,7 +5555,11 @@
               </a:defRPr>
             </a:pPr>
             <a:r>
-              <a:t>kappa=.5 remains reference-unresolved</a:t>
+              <a:rPr sz="1800" b="0">
+                <a:latin typeface="Arial"/>
+                <a:ea typeface="Arial"/>
+              </a:rPr>
+              <a:t>kappa=.5 fails reference peak selection</a:t>
             </a:r>
           </a:p>
           <a:p>
@@ -5299,6 +5575,10 @@
               </a:defRPr>
             </a:pPr>
             <a:r>
+              <a:rPr sz="1800" b="0">
+                <a:latin typeface="Arial"/>
+                <a:ea typeface="Arial"/>
+              </a:rPr>
               <a:t>Endpoints, multiple peaks and branch effects retained</a:t>
             </a:r>
           </a:p>
@@ -5315,6 +5595,10 @@
               </a:defRPr>
             </a:pPr>
             <a:r>
+              <a:rPr sz="1800" b="0">
+                <a:latin typeface="Arial"/>
+                <a:ea typeface="Arial"/>
+              </a:rPr>
               <a:t>Matching is finite-size evidence, not a phase certificate</a:t>
             </a:r>
           </a:p>
@@ -5322,14 +5606,14 @@
       </p:sp>
       <p:pic>
         <p:nvPicPr>
-          <p:cNvPr id="5" name="Picture 4" descr="Six complete 17-point windows; only five resolvable references"/>
+          <p:cNvPr id="5" name="Picture 4" descr="Six complete 17-point windows; five references pass peak selection"/>
           <p:cNvPicPr>
             <a:picLocks noChangeAspect="1"/>
           </p:cNvPicPr>
           <p:nvPr/>
         </p:nvPicPr>
         <p:blipFill>
-          <a:blip r:embed="rId2"/>
+          <a:blip r:embed="R69a1e5a2ab8d4e40"/>
           <a:stretch>
             <a:fillRect/>
           </a:stretch>
@@ -5361,7 +5645,7 @@
           <a:noFill/>
         </p:spPr>
         <p:txBody>
-          <a:bodyPr wrap="square" lIns="0" rIns="0" tIns="0">
+          <a:bodyPr wrap="square" lIns="0" tIns="0" rIns="0">
             <a:spAutoFit/>
           </a:bodyPr>
           <a:lstStyle/>
@@ -5418,7 +5702,7 @@
           <a:noFill/>
         </p:spPr>
         <p:txBody>
-          <a:bodyPr wrap="square" lIns="0" rIns="0" tIns="0">
+          <a:bodyPr wrap="square" lIns="0" tIns="0" rIns="0">
             <a:spAutoFit/>
           </a:bodyPr>
           <a:lstStyle/>
@@ -5435,6 +5719,10 @@
               </a:defRPr>
             </a:pPr>
             <a:r>
+              <a:rPr sz="3600" b="1">
+                <a:latin typeface="Arial"/>
+                <a:ea typeface="Arial"/>
+              </a:rPr>
               <a:t>Extensions expose the limits</a:t>
             </a:r>
           </a:p>
@@ -5457,7 +5745,7 @@
           <a:noFill/>
         </p:spPr>
         <p:txBody>
-          <a:bodyPr wrap="square" lIns="0" rIns="0" tIns="0">
+          <a:bodyPr wrap="square" lIns="0" tIns="0" rIns="0">
             <a:spAutoFit/>
           </a:bodyPr>
           <a:lstStyle/>
@@ -5474,6 +5762,10 @@
               </a:defRPr>
             </a:pPr>
             <a:r>
+              <a:rPr sz="2000" b="0">
+                <a:latin typeface="Arial"/>
+                <a:ea typeface="Arial"/>
+              </a:rPr>
               <a:t>H6 is a physical/domain-wall union, not the six-layer HVA</a:t>
             </a:r>
           </a:p>
@@ -5496,7 +5788,7 @@
           <a:noFill/>
         </p:spPr>
         <p:txBody>
-          <a:bodyPr wrap="square" lIns="0" rIns="0" tIns="0">
+          <a:bodyPr wrap="square" lIns="0" tIns="0" rIns="0">
             <a:spAutoFit/>
           </a:bodyPr>
           <a:lstStyle/>
@@ -5513,6 +5805,10 @@
               </a:defRPr>
             </a:pPr>
             <a:r>
+              <a:rPr sz="1800" b="0">
+                <a:latin typeface="Arial"/>
+                <a:ea typeface="Arial"/>
+              </a:rPr>
               <a:t>N8 low-field passes: 27/48 -&gt; 37/48, with more resources</a:t>
             </a:r>
           </a:p>
@@ -5529,6 +5825,10 @@
               </a:defRPr>
             </a:pPr>
             <a:r>
+              <a:rPr sz="1800" b="0">
+                <a:latin typeface="Arial"/>
+                <a:ea typeface="Arial"/>
+              </a:rPr>
               <a:t>N12 difficult/control transfer: 23/36 vs 17/36</a:t>
             </a:r>
           </a:p>
@@ -5545,6 +5845,10 @@
               </a:defRPr>
             </a:pPr>
             <a:r>
+              <a:rPr sz="1800" b="0">
+                <a:latin typeface="Arial"/>
+                <a:ea typeface="Arial"/>
+              </a:rPr>
               <a:t>Dynamics, multiple detectors and mitigation retained</a:t>
             </a:r>
           </a:p>
@@ -5559,14 +5863,14 @@
           <p:nvPr/>
         </p:nvPicPr>
         <p:blipFill>
-          <a:blip r:embed="rId2"/>
+          <a:blip r:embed="R60ad8e249a7c4d25"/>
           <a:stretch>
             <a:fillRect/>
           </a:stretch>
         </p:blipFill>
         <p:spPr>
           <a:xfrm>
-            <a:off x="2180710" y="2971800"/>
+            <a:off x="2180711" y="2971800"/>
             <a:ext cx="7830273" cy="3017520"/>
           </a:xfrm>
           <a:prstGeom prst="rect">
@@ -5591,7 +5895,7 @@
           <a:noFill/>
         </p:spPr>
         <p:txBody>
-          <a:bodyPr wrap="square" lIns="0" rIns="0" tIns="0">
+          <a:bodyPr wrap="square" lIns="0" tIns="0" rIns="0">
             <a:spAutoFit/>
           </a:bodyPr>
           <a:lstStyle/>
@@ -5648,7 +5952,7 @@
           <a:noFill/>
         </p:spPr>
         <p:txBody>
-          <a:bodyPr wrap="square" lIns="0" rIns="0" tIns="0">
+          <a:bodyPr wrap="square" lIns="0" tIns="0" rIns="0">
             <a:spAutoFit/>
           </a:bodyPr>
           <a:lstStyle/>
@@ -5665,6 +5969,10 @@
               </a:defRPr>
             </a:pPr>
             <a:r>
+              <a:rPr sz="3600" b="1">
+                <a:latin typeface="Arial"/>
+                <a:ea typeface="Arial"/>
+              </a:rPr>
               <a:t>What the evidence supports</a:t>
             </a:r>
           </a:p>
@@ -5687,7 +5995,7 @@
           <a:noFill/>
         </p:spPr>
         <p:txBody>
-          <a:bodyPr wrap="square" lIns="0" rIns="0" tIns="0">
+          <a:bodyPr wrap="square" lIns="0" tIns="0" rIns="0">
             <a:spAutoFit/>
           </a:bodyPr>
           <a:lstStyle/>
@@ -5704,6 +6012,10 @@
               </a:defRPr>
             </a:pPr>
             <a:r>
+              <a:rPr sz="2000" b="0">
+                <a:latin typeface="Arial"/>
+                <a:ea typeface="Arial"/>
+              </a:rPr>
               <a:t>A reproducible observable result with explicit phase-diagram limits</a:t>
             </a:r>
           </a:p>
@@ -5726,7 +6038,7 @@
           <a:noFill/>
         </p:spPr>
         <p:txBody>
-          <a:bodyPr wrap="square" lIns="0" rIns="0" tIns="0">
+          <a:bodyPr wrap="square" lIns="0" tIns="0" rIns="0">
             <a:spAutoFit/>
           </a:bodyPr>
           <a:lstStyle/>
@@ -5743,6 +6055,10 @@
               </a:defRPr>
             </a:pPr>
             <a:r>
+              <a:rPr sz="1800" b="0">
+                <a:latin typeface="Arial"/>
+                <a:ea typeface="Arial"/>
+              </a:rPr>
               <a:t>Lower-CNOT preparation helps noisy correlations</a:t>
             </a:r>
           </a:p>
@@ -5759,6 +6075,10 @@
               </a:defRPr>
             </a:pPr>
             <a:r>
+              <a:rPr sz="1800" b="0">
+                <a:latin typeface="Arial"/>
+                <a:ea typeface="Arial"/>
+              </a:rPr>
               <a:t>Equal-resource ZNE reduces bias, not every failure</a:t>
             </a:r>
           </a:p>
@@ -5775,7 +6095,11 @@
               </a:defRPr>
             </a:pPr>
             <a:r>
-              <a:t>No supported continuous floating interval</a:t>
+              <a:rPr sz="1800" b="0">
+                <a:latin typeface="Arial"/>
+                <a:ea typeface="Arial"/>
+              </a:rPr>
+              <a:t>Zero supported floating samples</a:t>
             </a:r>
           </a:p>
         </p:txBody>
@@ -5789,14 +6113,14 @@
           <p:nvPr/>
         </p:nvPicPr>
         <p:blipFill>
-          <a:blip r:embed="rId2"/>
+          <a:blip r:embed="R3d30389dcf9c4fe6"/>
           <a:stretch>
             <a:fillRect/>
           </a:stretch>
         </p:blipFill>
         <p:spPr>
           <a:xfrm>
-            <a:off x="855497" y="2971800"/>
+            <a:off x="855498" y="2971800"/>
             <a:ext cx="10480699" cy="3017520"/>
           </a:xfrm>
           <a:prstGeom prst="rect">
@@ -5821,7 +6145,7 @@
           <a:noFill/>
         </p:spPr>
         <p:txBody>
-          <a:bodyPr wrap="square" lIns="0" rIns="0" tIns="0">
+          <a:bodyPr wrap="square" lIns="0" tIns="0" rIns="0">
             <a:spAutoFit/>
           </a:bodyPr>
           <a:lstStyle/>

</xml_diff>

<commit_message>
Revise submission documentation and speaker notes
</commit_message>
<xml_diff>
--- a/presentation.pptx
+++ b/presentation.pptx
@@ -495,27 +495,6 @@
       </p:sp>
       <p:sp>
         <p:nvSpPr>
-          <p:cNvPr id="3" name="Notes Placeholder 2"/>
-          <p:cNvSpPr>
-            <a:spLocks noGrp="1"/>
-          </p:cNvSpPr>
-          <p:nvPr>
-            <p:ph type="body" sz="quarter" idx="3"/>
-          </p:nvPr>
-        </p:nvSpPr>
-        <p:spPr/>
-        <p:txBody>
-          <a:bodyPr/>
-          <a:lstStyle/>
-          <a:p>
-            <a:r>
-              <a:t>We study how quantum state preparation and noise affect reconstruction of the ANNNI phase diagram. The central result is a tradeoff: fewer entangling gates improve noisy correlations, and mitigation helps under a genuinely matched gate-weighted measurement budget. But neither improvement alone certifies a phase boundary. We keep the failed preparations, detector rejections and unresolved floating-phase evidence in the submission. The notebook contains the full numerical evidence and a lightweight circuit check.</a:t>
-            </a:r>
-          </a:p>
-        </p:txBody>
-      </p:sp>
-      <p:sp>
-        <p:nvSpPr>
           <p:cNvPr id="4" name="Slide Number Placeholder 3"/>
           <p:cNvSpPr>
             <a:spLocks noGrp="1"/>
@@ -541,7 +520,7 @@
           <a:p>
             <a:r>
               <a:rPr lang="en-US"/>
-              <a:t>We study how quantum state preparation and noise affect reconstruction of the ANNNI phase diagram. The central result is a tradeoff: fewer entangling gates improve noisy correlations, and mitigation helps under a genuinely matched gate-weighted measurement budget. But neither improvement alone certifies a phase boundary. We keep the failed preparations, detector rejections and floating-scan results in the submission. The notebook contains the full numerical evidence and a lightweight circuit check.</a:t>
+              <a:t>We study how quantum state preparation and noise affect reconstruction of the ANNNI phase diagram. Fewer entangling gates improve noisy correlations, and error mitigation helps when we match the gate-weighted measurement budget. Establishing a phase boundary requires separate evidence. The submission includes failed preparations, detector rejections and the floating-scan results. The notebook contains the full numerical evidence and a lightweight circuit check.</a:t>
             </a:r>
           </a:p>
         </p:txBody>
@@ -585,27 +564,6 @@
       </p:sp>
       <p:sp>
         <p:nvSpPr>
-          <p:cNvPr id="3" name="Notes Placeholder 2"/>
-          <p:cNvSpPr>
-            <a:spLocks noGrp="1"/>
-          </p:cNvSpPr>
-          <p:nvPr>
-            <p:ph type="body" sz="quarter" idx="3"/>
-          </p:nvPr>
-        </p:nvSpPr>
-        <p:spPr/>
-        <p:txBody>
-          <a:bodyPr/>
-          <a:lstStyle/>
-          <a:p>
-            <a:r>
-              <a:t>The Hamiltonian has ferromagnetic nearest-neighbor coupling, competing next-nearest-neighbor coupling and a transverse field. We use periodic boundaries for the small circuits. Noise follows every literal CNOT, on its target only, with the same specified channel at all three noise strengths. Reference preparation and folding count as gates. Three evidence layers prevent a detector from grading itself: supported interiors, same-size exact-diagonalization features, and larger-system evidence. Our observables retain every distance and momentum, including the self-correlation background.</a:t>
-            </a:r>
-          </a:p>
-        </p:txBody>
-      </p:sp>
-      <p:sp>
-        <p:nvSpPr>
           <p:cNvPr id="4" name="Slide Number Placeholder 3"/>
           <p:cNvSpPr>
             <a:spLocks noGrp="1"/>
@@ -631,7 +589,7 @@
           <a:p>
             <a:r>
               <a:rPr lang="en-US"/>
-              <a:t>The Hamiltonian has ferromagnetic nearest-neighbor coupling, competing next-nearest-neighbor coupling and a transverse field. We use periodic boundaries for the small circuits. Noise follows every literal CNOT, on its target only, with the same specified channel at all three noise strengths. Reference preparation and folding count as gates. Three evidence layers prevent a detector from grading itself: supported interiors, same-size exact-diagonalization features, and larger-system evidence. Our observables retain every distance and momentum, including the self-correlation background.</a:t>
+              <a:t>The Hamiltonian combines ferromagnetic nearest-neighbor coupling, competing next-nearest-neighbor coupling and a transverse field. Our small circuits use periodic boundaries. At each of the three noise strengths, the specified channel acts on the target after every literal CNOT, including reference preparation and folding. We distinguish supported interiors, same-size exact-diagonalization features and larger-system evidence so that detector output can be assessed against an independent reference. The observables include every distance and momentum, with the self-correlation background retained.</a:t>
             </a:r>
           </a:p>
         </p:txBody>
@@ -675,27 +633,6 @@
       </p:sp>
       <p:sp>
         <p:nvSpPr>
-          <p:cNvPr id="3" name="Notes Placeholder 2"/>
-          <p:cNvSpPr>
-            <a:spLocks noGrp="1"/>
-          </p:cNvSpPr>
-          <p:nvPr>
-            <p:ph type="body" sz="quarter" idx="3"/>
-          </p:nvPr>
-        </p:nvSpPr>
-        <p:spPr/>
-        <p:txBody>
-          <a:bodyPr/>
-          <a:lstStyle/>
-          <a:p>
-            <a:r>
-              <a:t>B0 is the original fixed six-layer Hamiltonian variational ansatz. B3 starts from several physical references and grows energy-optimized Pauli rotations, then uses a frozen energy and resource rule. The median CNOT count is halved, from 192 to 96. Ideal joint preparation coverage drops from 407 to 385 out of 420, so the method does not win on every metric. At noise probability one percent, mean maximum correlation error falls from 0.2638 to 0.1432, with improvement at 402 coordinates. This is an observable result, not phase-label accuracy.</a:t>
-            </a:r>
-          </a:p>
-        </p:txBody>
-      </p:sp>
-      <p:sp>
-        <p:nvSpPr>
           <p:cNvPr id="4" name="Slide Number Placeholder 3"/>
           <p:cNvSpPr>
             <a:spLocks noGrp="1"/>
@@ -721,7 +658,7 @@
           <a:p>
             <a:r>
               <a:rPr lang="en-US"/>
-              <a:t>B0 is the original fixed six-layer Hamiltonian variational ansatz. B3 starts from several physical references and grows energy-optimized Pauli rotations, then uses a frozen energy and resource rule. The median CNOT count is halved, from 192 to 96. Ideal joint preparation coverage drops from 407 to 385 out of 420, so the method does not win on every metric. At noise probability one percent, mean maximum correlation error falls from 0.2638 to 0.1432, with improvement at 402 coordinates. This is an observable result, not phase-label accuracy.</a:t>
+              <a:t>B0 is the original fixed six-layer Hamiltonian variational ansatz. B3 starts from several physical references, grows energy-optimized Pauli rotations and selects a circuit using a frozen energy and resource rule. The median CNOT count falls from 192 to 96, while ideal joint preparation coverage drops from 407 to 385 out of 420. At one percent noise, mean maximum correlation error falls from 0.2638 to 0.1432, with improvement at 402 coordinates. These measurements do not establish phase-label accuracy.</a:t>
             </a:r>
           </a:p>
         </p:txBody>
@@ -765,27 +702,6 @@
       </p:sp>
       <p:sp>
         <p:nvSpPr>
-          <p:cNvPr id="3" name="Notes Placeholder 2"/>
-          <p:cNvSpPr>
-            <a:spLocks noGrp="1"/>
-          </p:cNvSpPr>
-          <p:nvPr>
-            <p:ph type="body" sz="quarter" idx="3"/>
-          </p:nvPr>
-        </p:nvSpPr>
-        <p:spPr/>
-        <p:txBody>
-          <a:bodyPr/>
-          <a:lstStyle/>
-          <a:p>
-            <a:r>
-              <a:t>These are the required three noise maps, alongside the same detector applied to ED data. The method, grid and legend remain fixed across noise levels. The colors show resemblance to physical patterns, not independently validated truth at every coordinate. Crosses indicate failed ideal preparation without hiding the label. Our notebook separately displays single-repeat finite-shot maps and equal-shots mitigation maps. It also shows where independent region labels exist. We never extend the smaller equal-resource cohort into a full equal-resource map.</a:t>
-            </a:r>
-          </a:p>
-        </p:txBody>
-      </p:sp>
-      <p:sp>
-        <p:nvSpPr>
           <p:cNvPr id="4" name="Slide Number Placeholder 3"/>
           <p:cNvSpPr>
             <a:spLocks noGrp="1"/>
@@ -811,7 +727,7 @@
           <a:p>
             <a:r>
               <a:rPr lang="en-US"/>
-              <a:t>These are the required three noise maps, alongside the same detector applied to ED data. The method, grid and legend remain fixed across noise levels. The colors show resemblance to physical patterns, not independently validated truth at every coordinate. Crosses indicate failed ideal preparation without hiding the label. Our notebook separately displays single-repeat finite-shot maps and equal-shots mitigation maps. It also shows where independent region labels exist. We never extend the smaller equal-resource cohort into a full equal-resource map.</a:t>
+              <a:t>The three required noise maps appear alongside ED data classified by the same detector. We keep the method, grid and legend fixed across noise levels. Colors show resemblance to physical patterns; independent labels are available only at the coordinates shown in the notebook's reference panel. Crosses mark failed ideal preparations while leaving detector labels visible. The notebook also separates single-repeat finite-shot maps from equal-shots mitigation maps. The smaller equal-resource cohort is evaluated separately, without extrapolating it to a full map.</a:t>
             </a:r>
           </a:p>
         </p:txBody>
@@ -855,27 +771,6 @@
       </p:sp>
       <p:sp>
         <p:nvSpPr>
-          <p:cNvPr id="3" name="Notes Placeholder 2"/>
-          <p:cNvSpPr>
-            <a:spLocks noGrp="1"/>
-          </p:cNvSpPr>
-          <p:nvPr>
-            <p:ph type="body" sz="quarter" idx="3"/>
-          </p:nvPr>
-        </p:nvSpPr>
-        <p:spPr/>
-        <p:txBody>
-          <a:bodyPr/>
-          <a:lstStyle/>
-          <a:p>
-            <a:r>
-              <a:t>Equal shot counts alone favor extrapolation with more noisy gates. We therefore match the sum of shots times literal CNOTs at each coordinate. Raw and symmetry verification use one hundred thousand shots, whereas quadratic ZNE uses thirty-three thousand three hundred and thirty-four shots shared across the three folds. The integer gate-weighted costs match exactly. At p=.01 and .05 the mean ED-target MSE falls by 90.75 and 25.19 percent. Each of the 45 coordinate means improves. ZNE worsens all 45 at zero noise. It reduces bias while increasing sampling error, and only six coordinates have independent phase-interior labels.</a:t>
-            </a:r>
-          </a:p>
-        </p:txBody>
-      </p:sp>
-      <p:sp>
-        <p:nvSpPr>
           <p:cNvPr id="4" name="Slide Number Placeholder 3"/>
           <p:cNvSpPr>
             <a:spLocks noGrp="1"/>
@@ -901,7 +796,7 @@
           <a:p>
             <a:r>
               <a:rPr lang="en-US"/>
-              <a:t>Equal shot counts alone favor extrapolation with more noisy gates. We therefore match the sum of shots times literal CNOTs at each coordinate. Raw and symmetry verification use one hundred thousand shots, whereas quadratic ZNE uses thirty-three thousand three hundred and thirty-four shots shared across the three folds. The integer gate-weighted costs match exactly. At p=.01 and .05 the mean ED-target MSE falls by 90.75 and 25.19 percent. Each of the 45 coordinate means improves. ZNE worsens all 45 at zero noise. It reduces bias while increasing sampling error, and only six coordinates have independent phase-interior labels.</a:t>
+              <a:t>At equal shot counts, extrapolation receives more noisy gates. To control this cost, we match the sum of shots times literal CNOTs at each coordinate. Raw and symmetry verification use one hundred thousand shots; quadratic ZNE uses thirty-three thousand three hundred and thirty-four across the three folds. Their integer gate-weighted costs match exactly. At p=.01 and .05, mean ED-target MSE falls by 90.75 and 25.19 percent. All 45 coordinate means improve at these noise levels, but all 45 worsen at zero noise. ZNE reduces bias while increasing sampling error. Only six coordinates have independent phase-interior labels.</a:t>
             </a:r>
           </a:p>
         </p:txBody>
@@ -945,27 +840,6 @@
       </p:sp>
       <p:sp>
         <p:nvSpPr>
-          <p:cNvPr id="3" name="Notes Placeholder 2"/>
-          <p:cNvSpPr>
-            <a:spLocks noGrp="1"/>
-          </p:cNvSpPr>
-          <p:nvPr>
-            <p:ph type="body" sz="quarter" idx="3"/>
-          </p:nvPr>
-        </p:nvSpPr>
-        <p:spPr/>
-        <p:txBody>
-          <a:bodyPr/>
-          <a:lstStyle/>
-          <a:p>
-            <a:r>
-              <a:t>The prespecified kappa point eight window illustrates why a smaller component error need not stabilize a response feature. These curves use exact expectations so shot fluctuations cannot explain every failure. All six windows were actually executed. Five reference features are resolvable; the kappa point five reference is not. At strong noise, the equal-shots raw result matches roughly three of those five windows when averaged over measurement repeats, and extrapolation does not improve that aggregate. We retain endpoint and multiple-peak warnings, preparation failures and real same-coordinate branch comparisons. A match with no listed warning is still not proof of a thermodynamic transition.</a:t>
-            </a:r>
-          </a:p>
-        </p:txBody>
-      </p:sp>
-      <p:sp>
-        <p:nvSpPr>
           <p:cNvPr id="4" name="Slide Number Placeholder 3"/>
           <p:cNvSpPr>
             <a:spLocks noGrp="1"/>
@@ -991,7 +865,7 @@
           <a:p>
             <a:r>
               <a:rPr lang="en-US"/>
-              <a:t>The prespecified kappa point eight window illustrates the distinct outcomes of observable reconstruction and response-feature matching. These curves use exact expectations so shot fluctuations cannot explain every failure. All six windows were actually executed. Five reference features are resolvable; the kappa point five reference fails the frozen peak-selection criterion. At strong noise, the equal-shots raw result matches roughly three of those five windows when averaged over measurement repeats, and extrapolation does not improve that aggregate. We retain endpoint and multiple-peak warnings, preparation failures and real same-coordinate branch comparisons. A match with no listed warning is still not proof of a thermodynamic transition.</a:t>
+              <a:t>The prespecified kappa point eight window shows why observable reconstruction and response-feature matching need separate evaluation. These curves use exact expectations, so shot fluctuations cannot explain every failure. All six windows were executed. Five reference features are resolvable; the kappa point five reference fails the frozen peak-selection criterion. At strong noise, equal-shots raw estimates match roughly three of the five windows on average across measurement repeats. Extrapolation does not improve that aggregate. The records include endpoint and multiple-peak warnings, preparation failures and same-coordinate branch comparisons. Even a match without a listed warning requires more evidence to establish a thermodynamic transition.</a:t>
             </a:r>
           </a:p>
         </p:txBody>
@@ -1035,27 +909,6 @@
       </p:sp>
       <p:sp>
         <p:nvSpPr>
-          <p:cNvPr id="3" name="Notes Placeholder 2"/>
-          <p:cNvSpPr>
-            <a:spLocks noGrp="1"/>
-          </p:cNvSpPr>
-          <p:nvPr>
-            <p:ph type="body" sz="quarter" idx="3"/>
-          </p:nvPr>
-        </p:nvSpPr>
-        <p:spPr/>
-        <p:txBody>
-          <a:bodyPr/>
-          <a:lstStyle/>
-          <a:p>
-            <a:r>
-              <a:t>The newer physical and domain-wall construction improves selected joint passes in the independent low-field confirmation subset, from 27 to 37 out of 48. However, median CNOTs increase from 32 to 127 and objective calls increase by about seven and a half times. H6 therefore is not an equal-cost universal winner. Its transfer to the N12 difficult/control set is weaker than B3. The five extension topics remain in the package: larger circuits, multiple detectors, mitigation, dynamics, and the floating-phase search. The negative transfer result is preserved rather than removed from the final story.</a:t>
-            </a:r>
-          </a:p>
-        </p:txBody>
-      </p:sp>
-      <p:sp>
-        <p:nvSpPr>
           <p:cNvPr id="4" name="Slide Number Placeholder 3"/>
           <p:cNvSpPr>
             <a:spLocks noGrp="1"/>
@@ -1081,7 +934,7 @@
           <a:p>
             <a:r>
               <a:rPr lang="en-US"/>
-              <a:t>The newer physical and domain-wall construction improves selected joint passes in the independent low-field confirmation subset, from 27 to 37 out of 48. However, median CNOTs increase from 32 to 127 and objective calls increase by about seven and a half times. H6 therefore is not an equal-cost universal winner. Its transfer to the N12 difficult/control set is weaker than B3. The five extension topics remain in the package: larger circuits, multiple detectors, mitigation, dynamics, and the floating-phase search. The negative transfer result is preserved rather than removed from the final story.</a:t>
+              <a:t>Combining physical and domain-wall candidates increases selected joint passes in the independent low-field confirmation subset from 27 to 37 out of 48. That improvement costs more: median CNOTs rise from 32 to 127, and objective calls increase by about seven and a half times. On the N12 difficult/control set, H6 performs below B3. The package includes results for all five extension topics: larger circuits, multiple detectors, mitigation, dynamics and the floating-phase search.</a:t>
             </a:r>
           </a:p>
         </p:txBody>
@@ -1125,27 +978,6 @@
       </p:sp>
       <p:sp>
         <p:nvSpPr>
-          <p:cNvPr id="3" name="Notes Placeholder 2"/>
-          <p:cNvSpPr>
-            <a:spLocks noGrp="1"/>
-          </p:cNvSpPr>
-          <p:nvPr>
-            <p:ph type="body" sz="quarter" idx="3"/>
-          </p:nvPr>
-        </p:nvSpPr>
-        <p:spPr/>
-        <p:txBody>
-          <a:bodyPr/>
-          <a:lstStyle/>
-          <a:p>
-            <a:r>
-              <a:t>The controlled large-system slice supports an antiphase control at field point three and a paramagnetic-side control at point seven. Fields point four and point four two five remain candidates, but the size, entropy and Friedel evidence do not establish a supported floating interval or two independent transition brackets. A timed-out high-bond-dimension continuation is not evidence against a phase. Our conclusion is therefore specific: lower-gate preparation and resource-controlled mitigation improve observable reconstruction, while reliable boundary inference needs stronger evidence. The submission ships saved joint counts, gate tables, reproducible figures, and separate deterministic, physical and random-replay checks.</a:t>
-            </a:r>
-          </a:p>
-        </p:txBody>
-      </p:sp>
-      <p:sp>
-        <p:nvSpPr>
           <p:cNvPr id="4" name="Slide Number Placeholder 3"/>
           <p:cNvSpPr>
             <a:spLocks noGrp="1"/>
@@ -1171,7 +1003,7 @@
           <a:p>
             <a:r>
               <a:rPr lang="en-US"/>
-              <a:t>The controlled large-system slice supports an antiphase control at field point three and a paramagnetic-side control at point seven. Fields point four and point four two five have conflicting size, entropy and Friedel results. The final evidence contains zero supported floating samples and zero established transition brackets. A timed-out high-bond-dimension continuation is not evidence against a phase. Our conclusion is therefore specific: lower-gate preparation and resource-controlled mitigation improve observable reconstruction, while reliable boundary inference needs stronger evidence. The submission ships saved joint counts, gate tables, reproducible figures, and separate deterministic, physical and random-replay checks.</a:t>
+              <a:t>The controlled large-system slice supports an antiphase control at field point three and a paramagnetic-side control at point seven. At fields point four and point four two five, the size, entropy and Friedel diagnostics disagree. The final evidence contains zero supported floating samples and zero established transition brackets. The high-bond-dimension continuation reached its time limit, which gives no basis for excluding a phase. Lower-gate preparation and resource-controlled mitigation improve observable reconstruction in these experiments; reliable boundary inference needs stronger evidence. The submission includes saved joint counts, gate tables, reproducible figures and separate deterministic, physical and random-replay checks.</a:t>
             </a:r>
           </a:p>
         </p:txBody>

</xml_diff>